<commit_message>
M4: align report/notebook/slides with actual sklearn feature importances
</commit_message>
<xml_diff>
--- a/slides/York_CS4412_M4_Presentation.pptx
+++ b/slides/York_CS4412_M4_Presentation.pptx
@@ -7947,7 +7947,7 @@
                 </a:solidFill>
                 <a:latin typeface="Calibri"/>
               </a:rPr>
-              <a:t>Tier 1 split</a:t>
+              <a:t>Top of the tree</a:t>
             </a:r>
           </a:p>
           <a:p>
@@ -7959,7 +7959,7 @@
                 </a:solidFill>
                 <a:latin typeface="Calibri"/>
               </a:rPr>
-              <a:t>Overall production (OPS_plus_lg)</a:t>
+              <a:t>OPS_plus_lg ≈ 0.53 — the dominant</a:t>
             </a:r>
           </a:p>
           <a:p>
@@ -7971,7 +7971,19 @@
                 </a:solidFill>
                 <a:latin typeface="Calibri"/>
               </a:rPr>
-              <a:t>separates high vs. low producers.</a:t>
+              <a:t>split. Separates high vs. low</a:t>
+            </a:r>
+          </a:p>
+          <a:p>
+            <a:pPr algn="l"/>
+            <a:r>
+              <a:rPr sz="1400" b="0">
+                <a:solidFill>
+                  <a:srgbClr val="1A1A1A"/>
+                </a:solidFill>
+                <a:latin typeface="Calibri"/>
+              </a:rPr>
+              <a:t>producers.</a:t>
             </a:r>
           </a:p>
           <a:p>
@@ -7995,7 +8007,7 @@
                 </a:solidFill>
                 <a:latin typeface="Calibri"/>
               </a:rPr>
-              <a:t>Tier 2 splits</a:t>
+              <a:t>Secondary splits</a:t>
             </a:r>
           </a:p>
           <a:p>
@@ -8007,7 +8019,7 @@
                 </a:solidFill>
                 <a:latin typeface="Calibri"/>
               </a:rPr>
-              <a:t>HR and SO separate power vs.</a:t>
+              <a:t>HR ≈ 0.26 separates power; BA ≈</a:t>
             </a:r>
           </a:p>
           <a:p>
@@ -8019,7 +8031,7 @@
                 </a:solidFill>
                 <a:latin typeface="Calibri"/>
               </a:rPr>
-              <a:t>balanced and contact vs.</a:t>
+              <a:t>0.11 separates contact; SO ≈ 0.09</a:t>
             </a:r>
           </a:p>
           <a:p>
@@ -8031,7 +8043,7 @@
                 </a:solidFill>
                 <a:latin typeface="Calibri"/>
               </a:rPr>
-              <a:t>low-production within tier.</a:t>
+              <a:t>contributes a smaller share.</a:t>
             </a:r>
           </a:p>
           <a:p>
@@ -8067,7 +8079,7 @@
                 </a:solidFill>
                 <a:latin typeface="Calibri"/>
               </a:rPr>
-              <a:t>BA, OBP carry less standalone</a:t>
+              <a:t>OBP and SLG carry near-zero</a:t>
             </a:r>
           </a:p>
           <a:p>
@@ -8079,7 +8091,7 @@
                 </a:solidFill>
                 <a:latin typeface="Calibri"/>
               </a:rPr>
-              <a:t>weight — their info is absorbed</a:t>
+              <a:t>standalone weight — their info is</a:t>
             </a:r>
           </a:p>
           <a:p>
@@ -8091,7 +8103,7 @@
                 </a:solidFill>
                 <a:latin typeface="Calibri"/>
               </a:rPr>
-              <a:t>by OPS_plus_lg.</a:t>
+              <a:t>absorbed by OPS_plus_lg.</a:t>
             </a:r>
           </a:p>
         </p:txBody>

</xml_diff>

<commit_message>
Rename notebook to M4_analysis; correct date range to 1980-2021
</commit_message>
<xml_diff>
--- a/slides/York_CS4412_M4_Presentation.pptx
+++ b/slides/York_CS4412_M4_Presentation.pptx
@@ -4420,7 +4420,7 @@
                 </a:solidFill>
                 <a:latin typeface="Calibri"/>
               </a:rPr>
-              <a:t>Source: Lahman Baseball Database (SABR), 1980–2025.</a:t>
+              <a:t>Source: Lahman Baseball Database (SABR), 1980–2021.</a:t>
             </a:r>
           </a:p>
         </p:txBody>
@@ -4596,7 +4596,7 @@
                 </a:solidFill>
                 <a:latin typeface="Calibri"/>
               </a:rPr>
-              <a:t>Lahman Baseball Database, 1980–2025</a:t>
+              <a:t>Lahman Baseball Database, 1980–2021</a:t>
             </a:r>
           </a:p>
         </p:txBody>
@@ -4793,7 +4793,7 @@
                 </a:solidFill>
                 <a:latin typeface="Calibri"/>
               </a:rPr>
-              <a:t>46</a:t>
+              <a:t>42</a:t>
             </a:r>
           </a:p>
         </p:txBody>
@@ -4828,7 +4828,7 @@
                 </a:solidFill>
                 <a:latin typeface="Calibri"/>
               </a:rPr>
-              <a:t>seasons (1980–2025)</a:t>
+              <a:t>seasons (1980–2021)</a:t>
             </a:r>
           </a:p>
         </p:txBody>

</xml_diff>